<commit_message>
Add page number to zeroth review title slide for consistent numbering across all 9 slides
</commit_message>
<xml_diff>
--- a/slides/zeroth_review.pptx
+++ b/slides/zeroth_review.pptx
@@ -3332,6 +3332,41 @@
                 <a:latin typeface="Calibri"/>
               </a:rPr>
               <a:t>Course: 23AID201</a:t>
+            </a:r>
+          </a:p>
+        </p:txBody>
+      </p:sp>
+      <p:sp>
+        <p:nvSpPr>
+          <p:cNvPr id="8" name="TextBox 7"/>
+          <p:cNvSpPr txBox="1"/>
+          <p:nvPr/>
+        </p:nvSpPr>
+        <p:spPr>
+          <a:xfrm>
+            <a:off x="11155680" y="6446520"/>
+            <a:ext cx="822960" cy="320040"/>
+          </a:xfrm>
+          <a:prstGeom prst="rect">
+            <a:avLst/>
+          </a:prstGeom>
+          <a:noFill/>
+        </p:spPr>
+        <p:txBody>
+          <a:bodyPr wrap="square" anchor="t" lIns="0" rIns="0" tIns="0" bIns="0">
+            <a:spAutoFit/>
+          </a:bodyPr>
+          <a:lstStyle/>
+          <a:p>
+            <a:pPr algn="r"/>
+            <a:r>
+              <a:rPr sz="1100" b="0" i="0">
+                <a:solidFill>
+                  <a:srgbClr val="93C5FD"/>
+                </a:solidFill>
+                <a:latin typeface="Calibri"/>
+              </a:rPr>
+              <a:t>1 / 9</a:t>
             </a:r>
           </a:p>
         </p:txBody>

</xml_diff>